<commit_message>
Improve distractors and add progressive difficulty (A2→B1)
- Replace obvious distractors with confusing same-category alternatives
  (e.g., Bicycle vs Motorcycle/Scooter, Pancake vs Crepe/Waffle)
- Progressive difficulty: Sets 1-4 (A2), Sets 5-7 (A2-B1), Sets 8-10 (B1)
- B1 sets use longer descriptions, relative clauses, contrast expressions
- Add level badge on photo slides

https://claude.ai/code/session_01Lpkx4eyHaYt7VEUv5H2wHQ
</commit_message>
<xml_diff>
--- a/Speak_in_Circles_Activity.pptx
+++ b/Speak_in_Circles_Activity.pptx
@@ -3590,7 +3590,7 @@
               </a:defRPr>
             </a:pPr>
             <a:r>
-              <a:t>Speaking Activity  |  CEFR A1–A2  |  10 Sets</a:t>
+              <a:t>Speaking Activity  |  CEFR A2–B1 (Progressive)  |  10 Sets</a:t>
             </a:r>
           </a:p>
         </p:txBody>
@@ -3907,7 +3907,7 @@
               </a:defRPr>
             </a:pPr>
             <a:r>
-              <a:t>Answer: Piano</a:t>
+              <a:t>Answer: Violin</a:t>
             </a:r>
           </a:p>
         </p:txBody>
@@ -3986,7 +3986,7 @@
               </a:defRPr>
             </a:pPr>
             <a:r>
-              <a:t>keys — 鍵盤</a:t>
+              <a:t>strings — 弦</a:t>
             </a:r>
           </a:p>
         </p:txBody>
@@ -4065,7 +4065,7 @@
               </a:defRPr>
             </a:pPr>
             <a:r>
-              <a:t>black and white — 白と黒</a:t>
+              <a:t>bow — 弓（弦楽器を弾く道具）</a:t>
             </a:r>
           </a:p>
         </p:txBody>
@@ -4116,7 +4116,7 @@
                   <a:srgbClr val="333333"/>
                 </a:solidFill>
               </a:rPr>
-              <a:t>📝 Subject + have/has</a:t>
+              <a:t>📝 Subject + have/has + noun</a:t>
             </a:r>
           </a:p>
         </p:txBody>
@@ -4240,7 +4240,7 @@
               </a:defRPr>
             </a:pPr>
             <a:r>
-              <a:t>It is a big musical instrument. It has black and white keys. You press them with your fingers.</a:t>
+              <a:t>It has strings and you use a bow to play it. You hold it under your chin. It is smaller than a cello.</a:t>
             </a:r>
           </a:p>
         </p:txBody>
@@ -4387,6 +4387,57 @@
         </p:nvSpPr>
         <p:spPr>
           <a:xfrm>
+            <a:off x="4754880" y="182880"/>
+            <a:ext cx="1371600" cy="640080"/>
+          </a:xfrm>
+          <a:prstGeom prst="roundRect">
+            <a:avLst/>
+          </a:prstGeom>
+          <a:solidFill>
+            <a:srgbClr val="00B4D8"/>
+          </a:solidFill>
+          <a:ln>
+            <a:noFill/>
+          </a:ln>
+        </p:spPr>
+        <p:style>
+          <a:lnRef idx="1">
+            <a:schemeClr val="accent1"/>
+          </a:lnRef>
+          <a:fillRef idx="3">
+            <a:schemeClr val="accent1"/>
+          </a:fillRef>
+          <a:effectRef idx="2">
+            <a:schemeClr val="accent1"/>
+          </a:effectRef>
+          <a:fontRef idx="minor">
+            <a:schemeClr val="lt1"/>
+          </a:fontRef>
+        </p:style>
+        <p:txBody>
+          <a:bodyPr rtlCol="0" anchor="ctr"/>
+          <a:lstStyle/>
+          <a:p>
+            <a:pPr algn="ctr"/>
+            <a:r>
+              <a:rPr sz="1800" b="1">
+                <a:solidFill>
+                  <a:srgbClr val="FFFFFF"/>
+                </a:solidFill>
+              </a:rPr>
+              <a:t>A2</a:t>
+            </a:r>
+          </a:p>
+        </p:txBody>
+      </p:sp>
+      <p:sp>
+        <p:nvSpPr>
+          <p:cNvPr id="5" name="Rounded Rectangle 4"/>
+          <p:cNvSpPr/>
+          <p:nvPr/>
+        </p:nvSpPr>
+        <p:spPr>
+          <a:xfrm>
             <a:off x="8686800" y="182880"/>
             <a:ext cx="3200400" cy="640080"/>
           </a:xfrm>
@@ -4432,7 +4483,7 @@
       </p:sp>
       <p:sp>
         <p:nvSpPr>
-          <p:cNvPr id="5" name="Rounded Rectangle 4"/>
+          <p:cNvPr id="6" name="Rounded Rectangle 5"/>
           <p:cNvSpPr/>
           <p:nvPr/>
         </p:nvSpPr>
@@ -4477,7 +4528,7 @@
       </p:sp>
       <p:sp>
         <p:nvSpPr>
-          <p:cNvPr id="6" name="TextBox 5"/>
+          <p:cNvPr id="7" name="TextBox 6"/>
           <p:cNvSpPr txBox="1"/>
           <p:nvPr/>
         </p:nvSpPr>
@@ -4506,14 +4557,14 @@
               </a:defRPr>
             </a:pPr>
             <a:r>
-              <a:t>📷 Photo: Stylish sunglasses on a sunny beach</a:t>
-            </a:r>
-          </a:p>
-        </p:txBody>
-      </p:sp>
-      <p:sp>
-        <p:nvSpPr>
-          <p:cNvPr id="7" name="TextBox 6"/>
+              <a:t>📷 Photo: A person wearing sunglasses at the beach on a bright sunny day</a:t>
+            </a:r>
+          </a:p>
+        </p:txBody>
+      </p:sp>
+      <p:sp>
+        <p:nvSpPr>
+          <p:cNvPr id="8" name="TextBox 7"/>
           <p:cNvSpPr txBox="1"/>
           <p:nvPr/>
         </p:nvSpPr>
@@ -4549,7 +4600,7 @@
       </p:sp>
       <p:sp>
         <p:nvSpPr>
-          <p:cNvPr id="8" name="TextBox 7"/>
+          <p:cNvPr id="9" name="TextBox 8"/>
           <p:cNvSpPr txBox="1"/>
           <p:nvPr/>
         </p:nvSpPr>
@@ -4585,7 +4636,7 @@
       </p:sp>
       <p:sp>
         <p:nvSpPr>
-          <p:cNvPr id="9" name="Rounded Rectangle 8"/>
+          <p:cNvPr id="10" name="Rounded Rectangle 9"/>
           <p:cNvSpPr/>
           <p:nvPr/>
         </p:nvSpPr>
@@ -4948,7 +4999,7 @@
               </a:defRPr>
             </a:pPr>
             <a:r>
-              <a:t>Watch</a:t>
+              <a:t>Goggles</a:t>
             </a:r>
           </a:p>
         </p:txBody>
@@ -5216,7 +5267,7 @@
               </a:defRPr>
             </a:pPr>
             <a:r>
-              <a:t>Earphones</a:t>
+              <a:t>Reading Glasses</a:t>
             </a:r>
           </a:p>
         </p:txBody>
@@ -5648,7 +5699,7 @@
               </a:defRPr>
             </a:pPr>
             <a:r>
-              <a:t>protect — 守る</a:t>
+              <a:t>lenses — レンズ</a:t>
             </a:r>
           </a:p>
         </p:txBody>
@@ -5727,7 +5778,7 @@
               </a:defRPr>
             </a:pPr>
             <a:r>
-              <a:t>bright — まぶしい</a:t>
+              <a:t>shade — 日よけ、色の濃い部分</a:t>
             </a:r>
           </a:p>
         </p:txBody>
@@ -5778,7 +5829,7 @@
                   <a:srgbClr val="333333"/>
                 </a:solidFill>
               </a:rPr>
-              <a:t>📝 Plural: them/they</a:t>
+              <a:t>📝 Relative pronoun: that</a:t>
             </a:r>
           </a:p>
         </p:txBody>
@@ -5902,7 +5953,7 @@
               </a:defRPr>
             </a:pPr>
             <a:r>
-              <a:t>You wear them on your face. They protect your eyes from bright light on sunny days.</a:t>
+              <a:t>You wear them on your face outdoors. They have dark lenses that protect your eyes from the sun.</a:t>
             </a:r>
           </a:p>
         </p:txBody>
@@ -6049,6 +6100,57 @@
         </p:nvSpPr>
         <p:spPr>
           <a:xfrm>
+            <a:off x="4754880" y="182880"/>
+            <a:ext cx="1371600" cy="640080"/>
+          </a:xfrm>
+          <a:prstGeom prst="roundRect">
+            <a:avLst/>
+          </a:prstGeom>
+          <a:solidFill>
+            <a:srgbClr val="FF6B8A"/>
+          </a:solidFill>
+          <a:ln>
+            <a:noFill/>
+          </a:ln>
+        </p:spPr>
+        <p:style>
+          <a:lnRef idx="1">
+            <a:schemeClr val="accent1"/>
+          </a:lnRef>
+          <a:fillRef idx="3">
+            <a:schemeClr val="accent1"/>
+          </a:fillRef>
+          <a:effectRef idx="2">
+            <a:schemeClr val="accent1"/>
+          </a:effectRef>
+          <a:fontRef idx="minor">
+            <a:schemeClr val="lt1"/>
+          </a:fontRef>
+        </p:style>
+        <p:txBody>
+          <a:bodyPr rtlCol="0" anchor="ctr"/>
+          <a:lstStyle/>
+          <a:p>
+            <a:pPr algn="ctr"/>
+            <a:r>
+              <a:rPr sz="1800" b="1">
+                <a:solidFill>
+                  <a:srgbClr val="FFFFFF"/>
+                </a:solidFill>
+              </a:rPr>
+              <a:t>A2-B1</a:t>
+            </a:r>
+          </a:p>
+        </p:txBody>
+      </p:sp>
+      <p:sp>
+        <p:nvSpPr>
+          <p:cNvPr id="5" name="Rounded Rectangle 4"/>
+          <p:cNvSpPr/>
+          <p:nvPr/>
+        </p:nvSpPr>
+        <p:spPr>
+          <a:xfrm>
             <a:off x="8686800" y="182880"/>
             <a:ext cx="3200400" cy="640080"/>
           </a:xfrm>
@@ -6094,7 +6196,7 @@
       </p:sp>
       <p:sp>
         <p:nvSpPr>
-          <p:cNvPr id="5" name="Rounded Rectangle 4"/>
+          <p:cNvPr id="6" name="Rounded Rectangle 5"/>
           <p:cNvSpPr/>
           <p:nvPr/>
         </p:nvSpPr>
@@ -6139,7 +6241,7 @@
       </p:sp>
       <p:sp>
         <p:nvSpPr>
-          <p:cNvPr id="6" name="TextBox 5"/>
+          <p:cNvPr id="7" name="TextBox 6"/>
           <p:cNvSpPr txBox="1"/>
           <p:nvPr/>
         </p:nvSpPr>
@@ -6168,14 +6270,14 @@
               </a:defRPr>
             </a:pPr>
             <a:r>
-              <a:t>📷 Photo: A delicious cheese pizza with toppings on a wooden board</a:t>
-            </a:r>
-          </a:p>
-        </p:txBody>
-      </p:sp>
-      <p:sp>
-        <p:nvSpPr>
-          <p:cNvPr id="7" name="TextBox 6"/>
+              <a:t>📷 Photo: A stack of fluffy pancakes with syrup and butter on a plate</a:t>
+            </a:r>
+          </a:p>
+        </p:txBody>
+      </p:sp>
+      <p:sp>
+        <p:nvSpPr>
+          <p:cNvPr id="8" name="TextBox 7"/>
           <p:cNvSpPr txBox="1"/>
           <p:nvPr/>
         </p:nvSpPr>
@@ -6204,14 +6306,14 @@
               </a:defRPr>
             </a:pPr>
             <a:r>
-              <a:t>🍕</a:t>
-            </a:r>
-          </a:p>
-        </p:txBody>
-      </p:sp>
-      <p:sp>
-        <p:nvSpPr>
-          <p:cNvPr id="8" name="TextBox 7"/>
+              <a:t>🥞</a:t>
+            </a:r>
+          </a:p>
+        </p:txBody>
+      </p:sp>
+      <p:sp>
+        <p:nvSpPr>
+          <p:cNvPr id="9" name="TextBox 8"/>
           <p:cNvSpPr txBox="1"/>
           <p:nvPr/>
         </p:nvSpPr>
@@ -6247,7 +6349,7 @@
       </p:sp>
       <p:sp>
         <p:nvSpPr>
-          <p:cNvPr id="9" name="Rounded Rectangle 8"/>
+          <p:cNvPr id="10" name="Rounded Rectangle 9"/>
           <p:cNvSpPr/>
           <p:nvPr/>
         </p:nvSpPr>
@@ -6610,7 +6712,7 @@
               </a:defRPr>
             </a:pPr>
             <a:r>
-              <a:t>Sushi</a:t>
+              <a:t>Crepe</a:t>
             </a:r>
           </a:p>
         </p:txBody>
@@ -6744,7 +6846,7 @@
               </a:defRPr>
             </a:pPr>
             <a:r>
-              <a:t>Hamburger</a:t>
+              <a:t>Pancake</a:t>
             </a:r>
           </a:p>
         </p:txBody>
@@ -6878,7 +6980,7 @@
               </a:defRPr>
             </a:pPr>
             <a:r>
-              <a:t>Pizza</a:t>
+              <a:t>Waffle</a:t>
             </a:r>
           </a:p>
         </p:txBody>
@@ -6914,7 +7016,7 @@
               </a:defRPr>
             </a:pPr>
             <a:r>
-              <a:t>✅ Correct Answer: C</a:t>
+              <a:t>✅ Correct Answer: B</a:t>
             </a:r>
           </a:p>
         </p:txBody>
@@ -7231,7 +7333,7 @@
               </a:defRPr>
             </a:pPr>
             <a:r>
-              <a:t>Answer: Pizza</a:t>
+              <a:t>Answer: Pancake</a:t>
             </a:r>
           </a:p>
         </p:txBody>
@@ -7310,7 +7412,7 @@
               </a:defRPr>
             </a:pPr>
             <a:r>
-              <a:t>round — 丸い</a:t>
+              <a:t>batter — 生地（液状の）</a:t>
             </a:r>
           </a:p>
         </p:txBody>
@@ -7389,14 +7491,93 @@
               </a:defRPr>
             </a:pPr>
             <a:r>
-              <a:t>slice — 一切れ</a:t>
-            </a:r>
-          </a:p>
-        </p:txBody>
-      </p:sp>
-      <p:sp>
-        <p:nvSpPr>
-          <p:cNvPr id="12" name="Rounded Rectangle 11"/>
+              <a:t>fluffy — ふわふわの</a:t>
+            </a:r>
+          </a:p>
+        </p:txBody>
+      </p:sp>
+      <p:sp>
+        <p:nvSpPr>
+          <p:cNvPr id="12" name="Oval 11"/>
+          <p:cNvSpPr/>
+          <p:nvPr/>
+        </p:nvSpPr>
+        <p:spPr>
+          <a:xfrm>
+            <a:off x="1097280" y="3017520"/>
+            <a:ext cx="182880" cy="182880"/>
+          </a:xfrm>
+          <a:prstGeom prst="ellipse">
+            <a:avLst/>
+          </a:prstGeom>
+          <a:solidFill>
+            <a:srgbClr val="00B4D8"/>
+          </a:solidFill>
+          <a:ln>
+            <a:noFill/>
+          </a:ln>
+        </p:spPr>
+        <p:style>
+          <a:lnRef idx="1">
+            <a:schemeClr val="accent1"/>
+          </a:lnRef>
+          <a:fillRef idx="3">
+            <a:schemeClr val="accent1"/>
+          </a:fillRef>
+          <a:effectRef idx="2">
+            <a:schemeClr val="accent1"/>
+          </a:effectRef>
+          <a:fontRef idx="minor">
+            <a:schemeClr val="lt1"/>
+          </a:fontRef>
+        </p:style>
+        <p:txBody>
+          <a:bodyPr rtlCol="0" anchor="ctr"/>
+          <a:lstStyle/>
+          <a:p>
+            <a:pPr algn="ctr"/>
+          </a:p>
+        </p:txBody>
+      </p:sp>
+      <p:sp>
+        <p:nvSpPr>
+          <p:cNvPr id="13" name="TextBox 12"/>
+          <p:cNvSpPr txBox="1"/>
+          <p:nvPr/>
+        </p:nvSpPr>
+        <p:spPr>
+          <a:xfrm>
+            <a:off x="1463040" y="2926080"/>
+            <a:ext cx="9144000" cy="457200"/>
+          </a:xfrm>
+          <a:prstGeom prst="rect">
+            <a:avLst/>
+          </a:prstGeom>
+          <a:noFill/>
+        </p:spPr>
+        <p:txBody>
+          <a:bodyPr wrap="square" anchor="ctr">
+            <a:spAutoFit/>
+          </a:bodyPr>
+          <a:lstStyle/>
+          <a:p>
+            <a:pPr algn="l">
+              <a:defRPr sz="1800" b="1">
+                <a:solidFill>
+                  <a:srgbClr val="333333"/>
+                </a:solidFill>
+                <a:latin typeface="Calibri"/>
+              </a:defRPr>
+            </a:pPr>
+            <a:r>
+              <a:t>pour — 注ぐ</a:t>
+            </a:r>
+          </a:p>
+        </p:txBody>
+      </p:sp>
+      <p:sp>
+        <p:nvSpPr>
+          <p:cNvPr id="14" name="Rounded Rectangle 13"/>
           <p:cNvSpPr/>
           <p:nvPr/>
         </p:nvSpPr>
@@ -7440,14 +7621,14 @@
                   <a:srgbClr val="333333"/>
                 </a:solidFill>
               </a:rPr>
-              <a:t>📝 Passive meaning: It comes from ~</a:t>
-            </a:r>
-          </a:p>
-        </p:txBody>
-      </p:sp>
-      <p:sp>
-        <p:nvSpPr>
-          <p:cNvPr id="13" name="Rectangle 12"/>
+              <a:t>📝 Comparative: thicker / fluffier than ~</a:t>
+            </a:r>
+          </a:p>
+        </p:txBody>
+      </p:sp>
+      <p:sp>
+        <p:nvSpPr>
+          <p:cNvPr id="15" name="Rectangle 14"/>
           <p:cNvSpPr/>
           <p:nvPr/>
         </p:nvSpPr>
@@ -7490,7 +7671,7 @@
       </p:sp>
       <p:sp>
         <p:nvSpPr>
-          <p:cNvPr id="14" name="Rounded Rectangle 13"/>
+          <p:cNvPr id="16" name="Rounded Rectangle 15"/>
           <p:cNvSpPr/>
           <p:nvPr/>
         </p:nvSpPr>
@@ -7535,7 +7716,7 @@
       </p:sp>
       <p:sp>
         <p:nvSpPr>
-          <p:cNvPr id="15" name="TextBox 14"/>
+          <p:cNvPr id="17" name="TextBox 16"/>
           <p:cNvSpPr txBox="1"/>
           <p:nvPr/>
         </p:nvSpPr>
@@ -7564,7 +7745,7 @@
               </a:defRPr>
             </a:pPr>
             <a:r>
-              <a:t>It is round and you cut it into slices. It comes from Italy and has cheese on top.</a:t>
+              <a:t>You make it by pouring batter on a hot pan. It is round and flat, but thicker and fluffier than a crepe. People often eat it for breakfast with syrup.</a:t>
             </a:r>
           </a:p>
         </p:txBody>
@@ -7711,6 +7892,57 @@
         </p:nvSpPr>
         <p:spPr>
           <a:xfrm>
+            <a:off x="4754880" y="182880"/>
+            <a:ext cx="1371600" cy="640080"/>
+          </a:xfrm>
+          <a:prstGeom prst="roundRect">
+            <a:avLst/>
+          </a:prstGeom>
+          <a:solidFill>
+            <a:srgbClr val="FF6B8A"/>
+          </a:solidFill>
+          <a:ln>
+            <a:noFill/>
+          </a:ln>
+        </p:spPr>
+        <p:style>
+          <a:lnRef idx="1">
+            <a:schemeClr val="accent1"/>
+          </a:lnRef>
+          <a:fillRef idx="3">
+            <a:schemeClr val="accent1"/>
+          </a:fillRef>
+          <a:effectRef idx="2">
+            <a:schemeClr val="accent1"/>
+          </a:effectRef>
+          <a:fontRef idx="minor">
+            <a:schemeClr val="lt1"/>
+          </a:fontRef>
+        </p:style>
+        <p:txBody>
+          <a:bodyPr rtlCol="0" anchor="ctr"/>
+          <a:lstStyle/>
+          <a:p>
+            <a:pPr algn="ctr"/>
+            <a:r>
+              <a:rPr sz="1800" b="1">
+                <a:solidFill>
+                  <a:srgbClr val="FFFFFF"/>
+                </a:solidFill>
+              </a:rPr>
+              <a:t>A2-B1</a:t>
+            </a:r>
+          </a:p>
+        </p:txBody>
+      </p:sp>
+      <p:sp>
+        <p:nvSpPr>
+          <p:cNvPr id="5" name="Rounded Rectangle 4"/>
+          <p:cNvSpPr/>
+          <p:nvPr/>
+        </p:nvSpPr>
+        <p:spPr>
+          <a:xfrm>
             <a:off x="8686800" y="182880"/>
             <a:ext cx="3200400" cy="640080"/>
           </a:xfrm>
@@ -7756,7 +7988,7 @@
       </p:sp>
       <p:sp>
         <p:nvSpPr>
-          <p:cNvPr id="5" name="Rounded Rectangle 4"/>
+          <p:cNvPr id="6" name="Rounded Rectangle 5"/>
           <p:cNvSpPr/>
           <p:nvPr/>
         </p:nvSpPr>
@@ -7801,7 +8033,7 @@
       </p:sp>
       <p:sp>
         <p:nvSpPr>
-          <p:cNvPr id="6" name="TextBox 5"/>
+          <p:cNvPr id="7" name="TextBox 6"/>
           <p:cNvSpPr txBox="1"/>
           <p:nvPr/>
         </p:nvSpPr>
@@ -7830,14 +8062,14 @@
               </a:defRPr>
             </a:pPr>
             <a:r>
-              <a:t>📷 Photo: A person taking a photo with a digital camera at a tourist spot</a:t>
-            </a:r>
-          </a:p>
-        </p:txBody>
-      </p:sp>
-      <p:sp>
-        <p:nvSpPr>
-          <p:cNvPr id="7" name="TextBox 6"/>
+              <a:t>📷 Photo: A scientist looking through a microscope in a laboratory</a:t>
+            </a:r>
+          </a:p>
+        </p:txBody>
+      </p:sp>
+      <p:sp>
+        <p:nvSpPr>
+          <p:cNvPr id="8" name="TextBox 7"/>
           <p:cNvSpPr txBox="1"/>
           <p:nvPr/>
         </p:nvSpPr>
@@ -7866,14 +8098,14 @@
               </a:defRPr>
             </a:pPr>
             <a:r>
-              <a:t>📷</a:t>
-            </a:r>
-          </a:p>
-        </p:txBody>
-      </p:sp>
-      <p:sp>
-        <p:nvSpPr>
-          <p:cNvPr id="8" name="TextBox 7"/>
+              <a:t>🔬</a:t>
+            </a:r>
+          </a:p>
+        </p:txBody>
+      </p:sp>
+      <p:sp>
+        <p:nvSpPr>
+          <p:cNvPr id="9" name="TextBox 8"/>
           <p:cNvSpPr txBox="1"/>
           <p:nvPr/>
         </p:nvSpPr>
@@ -7909,7 +8141,7 @@
       </p:sp>
       <p:sp>
         <p:nvSpPr>
-          <p:cNvPr id="9" name="Rounded Rectangle 8"/>
+          <p:cNvPr id="10" name="Rounded Rectangle 9"/>
           <p:cNvSpPr/>
           <p:nvPr/>
         </p:nvSpPr>
@@ -8272,7 +8504,7 @@
               </a:defRPr>
             </a:pPr>
             <a:r>
-              <a:t>Camera</a:t>
+              <a:t>Telescope</a:t>
             </a:r>
           </a:p>
         </p:txBody>
@@ -8406,7 +8638,7 @@
               </a:defRPr>
             </a:pPr>
             <a:r>
-              <a:t>Smartphone</a:t>
+              <a:t>Microscope</a:t>
             </a:r>
           </a:p>
         </p:txBody>
@@ -8540,7 +8772,7 @@
               </a:defRPr>
             </a:pPr>
             <a:r>
-              <a:t>Telescope</a:t>
+              <a:t>Binoculars</a:t>
             </a:r>
           </a:p>
         </p:txBody>
@@ -8576,7 +8808,7 @@
               </a:defRPr>
             </a:pPr>
             <a:r>
-              <a:t>✅ Correct Answer: A</a:t>
+              <a:t>✅ Correct Answer: B</a:t>
             </a:r>
           </a:p>
         </p:txBody>
@@ -8893,7 +9125,7 @@
               </a:defRPr>
             </a:pPr>
             <a:r>
-              <a:t>Answer: Camera</a:t>
+              <a:t>Answer: Microscope</a:t>
             </a:r>
           </a:p>
         </p:txBody>
@@ -8972,7 +9204,7 @@
               </a:defRPr>
             </a:pPr>
             <a:r>
-              <a:t>take a picture — 写真を撮る</a:t>
+              <a:t>magnify — 拡大する</a:t>
             </a:r>
           </a:p>
         </p:txBody>
@@ -9051,14 +9283,93 @@
               </a:defRPr>
             </a:pPr>
             <a:r>
-              <a:t>moment — 瞬間</a:t>
-            </a:r>
-          </a:p>
-        </p:txBody>
-      </p:sp>
-      <p:sp>
-        <p:nvSpPr>
-          <p:cNvPr id="12" name="Rounded Rectangle 11"/>
+              <a:t>lens — レンズ</a:t>
+            </a:r>
+          </a:p>
+        </p:txBody>
+      </p:sp>
+      <p:sp>
+        <p:nvSpPr>
+          <p:cNvPr id="12" name="Oval 11"/>
+          <p:cNvSpPr/>
+          <p:nvPr/>
+        </p:nvSpPr>
+        <p:spPr>
+          <a:xfrm>
+            <a:off x="1097280" y="3017520"/>
+            <a:ext cx="182880" cy="182880"/>
+          </a:xfrm>
+          <a:prstGeom prst="ellipse">
+            <a:avLst/>
+          </a:prstGeom>
+          <a:solidFill>
+            <a:srgbClr val="00B4D8"/>
+          </a:solidFill>
+          <a:ln>
+            <a:noFill/>
+          </a:ln>
+        </p:spPr>
+        <p:style>
+          <a:lnRef idx="1">
+            <a:schemeClr val="accent1"/>
+          </a:lnRef>
+          <a:fillRef idx="3">
+            <a:schemeClr val="accent1"/>
+          </a:fillRef>
+          <a:effectRef idx="2">
+            <a:schemeClr val="accent1"/>
+          </a:effectRef>
+          <a:fontRef idx="minor">
+            <a:schemeClr val="lt1"/>
+          </a:fontRef>
+        </p:style>
+        <p:txBody>
+          <a:bodyPr rtlCol="0" anchor="ctr"/>
+          <a:lstStyle/>
+          <a:p>
+            <a:pPr algn="ctr"/>
+          </a:p>
+        </p:txBody>
+      </p:sp>
+      <p:sp>
+        <p:nvSpPr>
+          <p:cNvPr id="13" name="TextBox 12"/>
+          <p:cNvSpPr txBox="1"/>
+          <p:nvPr/>
+        </p:nvSpPr>
+        <p:spPr>
+          <a:xfrm>
+            <a:off x="1463040" y="2926080"/>
+            <a:ext cx="9144000" cy="457200"/>
+          </a:xfrm>
+          <a:prstGeom prst="rect">
+            <a:avLst/>
+          </a:prstGeom>
+          <a:noFill/>
+        </p:spPr>
+        <p:txBody>
+          <a:bodyPr wrap="square" anchor="ctr">
+            <a:spAutoFit/>
+          </a:bodyPr>
+          <a:lstStyle/>
+          <a:p>
+            <a:pPr algn="l">
+              <a:defRPr sz="1800" b="1">
+                <a:solidFill>
+                  <a:srgbClr val="333333"/>
+                </a:solidFill>
+                <a:latin typeface="Calibri"/>
+              </a:defRPr>
+            </a:pPr>
+            <a:r>
+              <a:t>tiny — とても小さい</a:t>
+            </a:r>
+          </a:p>
+        </p:txBody>
+      </p:sp>
+      <p:sp>
+        <p:nvSpPr>
+          <p:cNvPr id="14" name="Rounded Rectangle 13"/>
           <p:cNvSpPr/>
           <p:nvPr/>
         </p:nvSpPr>
@@ -9102,14 +9413,14 @@
                   <a:srgbClr val="333333"/>
                 </a:solidFill>
               </a:rPr>
-              <a:t>📝 Infinitive: to + verb</a:t>
-            </a:r>
-          </a:p>
-        </p:txBody>
-      </p:sp>
-      <p:sp>
-        <p:nvSpPr>
-          <p:cNvPr id="13" name="Rectangle 12"/>
+              <a:t>📝 Passive: It is used to ~</a:t>
+            </a:r>
+          </a:p>
+        </p:txBody>
+      </p:sp>
+      <p:sp>
+        <p:nvSpPr>
+          <p:cNvPr id="15" name="Rectangle 14"/>
           <p:cNvSpPr/>
           <p:nvPr/>
         </p:nvSpPr>
@@ -9152,7 +9463,7 @@
       </p:sp>
       <p:sp>
         <p:nvSpPr>
-          <p:cNvPr id="14" name="Rounded Rectangle 13"/>
+          <p:cNvPr id="16" name="Rounded Rectangle 15"/>
           <p:cNvSpPr/>
           <p:nvPr/>
         </p:nvSpPr>
@@ -9197,7 +9508,7 @@
       </p:sp>
       <p:sp>
         <p:nvSpPr>
-          <p:cNvPr id="15" name="TextBox 14"/>
+          <p:cNvPr id="17" name="TextBox 16"/>
           <p:cNvSpPr txBox="1"/>
           <p:nvPr/>
         </p:nvSpPr>
@@ -9226,7 +9537,7 @@
               </a:defRPr>
             </a:pPr>
             <a:r>
-              <a:t>You use it to take pictures. You press a button and it saves the moment.</a:t>
+              <a:t>It is used in science class to look at very tiny things. It magnifies objects that are too small for your eyes. Unlike a telescope, you look down into it.</a:t>
             </a:r>
           </a:p>
         </p:txBody>
@@ -9373,6 +9684,57 @@
         </p:nvSpPr>
         <p:spPr>
           <a:xfrm>
+            <a:off x="4754880" y="182880"/>
+            <a:ext cx="1371600" cy="640080"/>
+          </a:xfrm>
+          <a:prstGeom prst="roundRect">
+            <a:avLst/>
+          </a:prstGeom>
+          <a:solidFill>
+            <a:srgbClr val="00B4D8"/>
+          </a:solidFill>
+          <a:ln>
+            <a:noFill/>
+          </a:ln>
+        </p:spPr>
+        <p:style>
+          <a:lnRef idx="1">
+            <a:schemeClr val="accent1"/>
+          </a:lnRef>
+          <a:fillRef idx="3">
+            <a:schemeClr val="accent1"/>
+          </a:fillRef>
+          <a:effectRef idx="2">
+            <a:schemeClr val="accent1"/>
+          </a:effectRef>
+          <a:fontRef idx="minor">
+            <a:schemeClr val="lt1"/>
+          </a:fontRef>
+        </p:style>
+        <p:txBody>
+          <a:bodyPr rtlCol="0" anchor="ctr"/>
+          <a:lstStyle/>
+          <a:p>
+            <a:pPr algn="ctr"/>
+            <a:r>
+              <a:rPr sz="1800" b="1">
+                <a:solidFill>
+                  <a:srgbClr val="FFFFFF"/>
+                </a:solidFill>
+              </a:rPr>
+              <a:t>A2</a:t>
+            </a:r>
+          </a:p>
+        </p:txBody>
+      </p:sp>
+      <p:sp>
+        <p:nvSpPr>
+          <p:cNvPr id="5" name="Rounded Rectangle 4"/>
+          <p:cNvSpPr/>
+          <p:nvPr/>
+        </p:nvSpPr>
+        <p:spPr>
+          <a:xfrm>
             <a:off x="8686800" y="182880"/>
             <a:ext cx="3200400" cy="640080"/>
           </a:xfrm>
@@ -9418,7 +9780,7 @@
       </p:sp>
       <p:sp>
         <p:nvSpPr>
-          <p:cNvPr id="5" name="Rounded Rectangle 4"/>
+          <p:cNvPr id="6" name="Rounded Rectangle 5"/>
           <p:cNvSpPr/>
           <p:nvPr/>
         </p:nvSpPr>
@@ -9463,7 +9825,7 @@
       </p:sp>
       <p:sp>
         <p:nvSpPr>
-          <p:cNvPr id="6" name="TextBox 5"/>
+          <p:cNvPr id="7" name="TextBox 6"/>
           <p:cNvSpPr txBox="1"/>
           <p:nvPr/>
         </p:nvSpPr>
@@ -9499,7 +9861,7 @@
       </p:sp>
       <p:sp>
         <p:nvSpPr>
-          <p:cNvPr id="7" name="TextBox 6"/>
+          <p:cNvPr id="8" name="TextBox 7"/>
           <p:cNvSpPr txBox="1"/>
           <p:nvPr/>
         </p:nvSpPr>
@@ -9535,7 +9897,7 @@
       </p:sp>
       <p:sp>
         <p:nvSpPr>
-          <p:cNvPr id="8" name="TextBox 7"/>
+          <p:cNvPr id="9" name="TextBox 8"/>
           <p:cNvSpPr txBox="1"/>
           <p:nvPr/>
         </p:nvSpPr>
@@ -9571,7 +9933,7 @@
       </p:sp>
       <p:sp>
         <p:nvSpPr>
-          <p:cNvPr id="9" name="Rounded Rectangle 8"/>
+          <p:cNvPr id="10" name="Rounded Rectangle 9"/>
           <p:cNvSpPr/>
           <p:nvPr/>
         </p:nvSpPr>
@@ -9762,6 +10124,57 @@
         </p:nvSpPr>
         <p:spPr>
           <a:xfrm>
+            <a:off x="4754880" y="182880"/>
+            <a:ext cx="1371600" cy="640080"/>
+          </a:xfrm>
+          <a:prstGeom prst="roundRect">
+            <a:avLst/>
+          </a:prstGeom>
+          <a:solidFill>
+            <a:srgbClr val="FF6B8A"/>
+          </a:solidFill>
+          <a:ln>
+            <a:noFill/>
+          </a:ln>
+        </p:spPr>
+        <p:style>
+          <a:lnRef idx="1">
+            <a:schemeClr val="accent1"/>
+          </a:lnRef>
+          <a:fillRef idx="3">
+            <a:schemeClr val="accent1"/>
+          </a:fillRef>
+          <a:effectRef idx="2">
+            <a:schemeClr val="accent1"/>
+          </a:effectRef>
+          <a:fontRef idx="minor">
+            <a:schemeClr val="lt1"/>
+          </a:fontRef>
+        </p:style>
+        <p:txBody>
+          <a:bodyPr rtlCol="0" anchor="ctr"/>
+          <a:lstStyle/>
+          <a:p>
+            <a:pPr algn="ctr"/>
+            <a:r>
+              <a:rPr sz="1800" b="1">
+                <a:solidFill>
+                  <a:srgbClr val="FFFFFF"/>
+                </a:solidFill>
+              </a:rPr>
+              <a:t>A2-B1</a:t>
+            </a:r>
+          </a:p>
+        </p:txBody>
+      </p:sp>
+      <p:sp>
+        <p:nvSpPr>
+          <p:cNvPr id="5" name="Rounded Rectangle 4"/>
+          <p:cNvSpPr/>
+          <p:nvPr/>
+        </p:nvSpPr>
+        <p:spPr>
+          <a:xfrm>
             <a:off x="8686800" y="182880"/>
             <a:ext cx="3200400" cy="640080"/>
           </a:xfrm>
@@ -9807,7 +10220,7 @@
       </p:sp>
       <p:sp>
         <p:nvSpPr>
-          <p:cNvPr id="5" name="Rounded Rectangle 4"/>
+          <p:cNvPr id="6" name="Rounded Rectangle 5"/>
           <p:cNvSpPr/>
           <p:nvPr/>
         </p:nvSpPr>
@@ -9852,7 +10265,7 @@
       </p:sp>
       <p:sp>
         <p:nvSpPr>
-          <p:cNvPr id="6" name="TextBox 5"/>
+          <p:cNvPr id="7" name="TextBox 6"/>
           <p:cNvSpPr txBox="1"/>
           <p:nvPr/>
         </p:nvSpPr>
@@ -9881,14 +10294,14 @@
               </a:defRPr>
             </a:pPr>
             <a:r>
-              <a:t>📷 Photo: A large clock on a wall showing the time</a:t>
-            </a:r>
-          </a:p>
-        </p:txBody>
-      </p:sp>
-      <p:sp>
-        <p:nvSpPr>
-          <p:cNvPr id="7" name="TextBox 6"/>
+              <a:t>📷 Photo: A digital thermometer showing a person's body temperature</a:t>
+            </a:r>
+          </a:p>
+        </p:txBody>
+      </p:sp>
+      <p:sp>
+        <p:nvSpPr>
+          <p:cNvPr id="8" name="TextBox 7"/>
           <p:cNvSpPr txBox="1"/>
           <p:nvPr/>
         </p:nvSpPr>
@@ -9917,14 +10330,14 @@
               </a:defRPr>
             </a:pPr>
             <a:r>
-              <a:t>🕐</a:t>
-            </a:r>
-          </a:p>
-        </p:txBody>
-      </p:sp>
-      <p:sp>
-        <p:nvSpPr>
-          <p:cNvPr id="8" name="TextBox 7"/>
+              <a:t>🌡️</a:t>
+            </a:r>
+          </a:p>
+        </p:txBody>
+      </p:sp>
+      <p:sp>
+        <p:nvSpPr>
+          <p:cNvPr id="9" name="TextBox 8"/>
           <p:cNvSpPr txBox="1"/>
           <p:nvPr/>
         </p:nvSpPr>
@@ -9960,7 +10373,7 @@
       </p:sp>
       <p:sp>
         <p:nvSpPr>
-          <p:cNvPr id="9" name="Rounded Rectangle 8"/>
+          <p:cNvPr id="10" name="Rounded Rectangle 9"/>
           <p:cNvSpPr/>
           <p:nvPr/>
         </p:nvSpPr>
@@ -10323,7 +10736,7 @@
               </a:defRPr>
             </a:pPr>
             <a:r>
-              <a:t>Calendar</a:t>
+              <a:t>Thermometer</a:t>
             </a:r>
           </a:p>
         </p:txBody>
@@ -10457,7 +10870,7 @@
               </a:defRPr>
             </a:pPr>
             <a:r>
-              <a:t>Clock</a:t>
+              <a:t>Barometer</a:t>
             </a:r>
           </a:p>
         </p:txBody>
@@ -10591,7 +11004,7 @@
               </a:defRPr>
             </a:pPr>
             <a:r>
-              <a:t>Thermometer</a:t>
+              <a:t>Stopwatch</a:t>
             </a:r>
           </a:p>
         </p:txBody>
@@ -10627,7 +11040,7 @@
               </a:defRPr>
             </a:pPr>
             <a:r>
-              <a:t>✅ Correct Answer: B</a:t>
+              <a:t>✅ Correct Answer: A</a:t>
             </a:r>
           </a:p>
         </p:txBody>
@@ -10944,7 +11357,7 @@
               </a:defRPr>
             </a:pPr>
             <a:r>
-              <a:t>Answer: Clock</a:t>
+              <a:t>Answer: Thermometer</a:t>
             </a:r>
           </a:p>
         </p:txBody>
@@ -11023,7 +11436,7 @@
               </a:defRPr>
             </a:pPr>
             <a:r>
-              <a:t>hands — 針</a:t>
+              <a:t>temperature — 温度</a:t>
             </a:r>
           </a:p>
         </p:txBody>
@@ -11102,14 +11515,93 @@
               </a:defRPr>
             </a:pPr>
             <a:r>
-              <a:t>tell the time — 時間を教える</a:t>
-            </a:r>
-          </a:p>
-        </p:txBody>
-      </p:sp>
-      <p:sp>
-        <p:nvSpPr>
-          <p:cNvPr id="12" name="Rounded Rectangle 11"/>
+              <a:t>measure — 測る</a:t>
+            </a:r>
+          </a:p>
+        </p:txBody>
+      </p:sp>
+      <p:sp>
+        <p:nvSpPr>
+          <p:cNvPr id="12" name="Oval 11"/>
+          <p:cNvSpPr/>
+          <p:nvPr/>
+        </p:nvSpPr>
+        <p:spPr>
+          <a:xfrm>
+            <a:off x="1097280" y="3017520"/>
+            <a:ext cx="182880" cy="182880"/>
+          </a:xfrm>
+          <a:prstGeom prst="ellipse">
+            <a:avLst/>
+          </a:prstGeom>
+          <a:solidFill>
+            <a:srgbClr val="00B4D8"/>
+          </a:solidFill>
+          <a:ln>
+            <a:noFill/>
+          </a:ln>
+        </p:spPr>
+        <p:style>
+          <a:lnRef idx="1">
+            <a:schemeClr val="accent1"/>
+          </a:lnRef>
+          <a:fillRef idx="3">
+            <a:schemeClr val="accent1"/>
+          </a:fillRef>
+          <a:effectRef idx="2">
+            <a:schemeClr val="accent1"/>
+          </a:effectRef>
+          <a:fontRef idx="minor">
+            <a:schemeClr val="lt1"/>
+          </a:fontRef>
+        </p:style>
+        <p:txBody>
+          <a:bodyPr rtlCol="0" anchor="ctr"/>
+          <a:lstStyle/>
+          <a:p>
+            <a:pPr algn="ctr"/>
+          </a:p>
+        </p:txBody>
+      </p:sp>
+      <p:sp>
+        <p:nvSpPr>
+          <p:cNvPr id="13" name="TextBox 12"/>
+          <p:cNvSpPr txBox="1"/>
+          <p:nvPr/>
+        </p:nvSpPr>
+        <p:spPr>
+          <a:xfrm>
+            <a:off x="1463040" y="2926080"/>
+            <a:ext cx="9144000" cy="457200"/>
+          </a:xfrm>
+          <a:prstGeom prst="rect">
+            <a:avLst/>
+          </a:prstGeom>
+          <a:noFill/>
+        </p:spPr>
+        <p:txBody>
+          <a:bodyPr wrap="square" anchor="ctr">
+            <a:spAutoFit/>
+          </a:bodyPr>
+          <a:lstStyle/>
+          <a:p>
+            <a:pPr algn="l">
+              <a:defRPr sz="1800" b="1">
+                <a:solidFill>
+                  <a:srgbClr val="333333"/>
+                </a:solidFill>
+                <a:latin typeface="Calibri"/>
+              </a:defRPr>
+            </a:pPr>
+            <a:r>
+              <a:t>fever — 熱</a:t>
+            </a:r>
+          </a:p>
+        </p:txBody>
+      </p:sp>
+      <p:sp>
+        <p:nvSpPr>
+          <p:cNvPr id="14" name="Rounded Rectangle 13"/>
           <p:cNvSpPr/>
           <p:nvPr/>
         </p:nvSpPr>
@@ -11153,14 +11645,14 @@
                   <a:srgbClr val="333333"/>
                 </a:solidFill>
               </a:rPr>
-              <a:t>📝 Subject + tell + object</a:t>
-            </a:r>
-          </a:p>
-        </p:txBody>
-      </p:sp>
-      <p:sp>
-        <p:nvSpPr>
-          <p:cNvPr id="13" name="Rectangle 12"/>
+              <a:t>📝 Interrogative: how + adjective</a:t>
+            </a:r>
+          </a:p>
+        </p:txBody>
+      </p:sp>
+      <p:sp>
+        <p:nvSpPr>
+          <p:cNvPr id="15" name="Rectangle 14"/>
           <p:cNvSpPr/>
           <p:nvPr/>
         </p:nvSpPr>
@@ -11203,7 +11695,7 @@
       </p:sp>
       <p:sp>
         <p:nvSpPr>
-          <p:cNvPr id="14" name="Rounded Rectangle 13"/>
+          <p:cNvPr id="16" name="Rounded Rectangle 15"/>
           <p:cNvSpPr/>
           <p:nvPr/>
         </p:nvSpPr>
@@ -11248,7 +11740,7 @@
       </p:sp>
       <p:sp>
         <p:nvSpPr>
-          <p:cNvPr id="15" name="TextBox 14"/>
+          <p:cNvPr id="17" name="TextBox 16"/>
           <p:cNvSpPr txBox="1"/>
           <p:nvPr/>
         </p:nvSpPr>
@@ -11277,7 +11769,7 @@
               </a:defRPr>
             </a:pPr>
             <a:r>
-              <a:t>It is on the wall. It has numbers and hands. It tells you the time.</a:t>
+              <a:t>You use it to measure how hot or cold something is. When you are sick, your mother may put it in your mouth to check if you have a fever.</a:t>
             </a:r>
           </a:p>
         </p:txBody>
@@ -11424,6 +11916,57 @@
         </p:nvSpPr>
         <p:spPr>
           <a:xfrm>
+            <a:off x="4754880" y="182880"/>
+            <a:ext cx="1371600" cy="640080"/>
+          </a:xfrm>
+          <a:prstGeom prst="roundRect">
+            <a:avLst/>
+          </a:prstGeom>
+          <a:solidFill>
+            <a:srgbClr val="FF4500"/>
+          </a:solidFill>
+          <a:ln>
+            <a:noFill/>
+          </a:ln>
+        </p:spPr>
+        <p:style>
+          <a:lnRef idx="1">
+            <a:schemeClr val="accent1"/>
+          </a:lnRef>
+          <a:fillRef idx="3">
+            <a:schemeClr val="accent1"/>
+          </a:fillRef>
+          <a:effectRef idx="2">
+            <a:schemeClr val="accent1"/>
+          </a:effectRef>
+          <a:fontRef idx="minor">
+            <a:schemeClr val="lt1"/>
+          </a:fontRef>
+        </p:style>
+        <p:txBody>
+          <a:bodyPr rtlCol="0" anchor="ctr"/>
+          <a:lstStyle/>
+          <a:p>
+            <a:pPr algn="ctr"/>
+            <a:r>
+              <a:rPr sz="1800" b="1">
+                <a:solidFill>
+                  <a:srgbClr val="FFFFFF"/>
+                </a:solidFill>
+              </a:rPr>
+              <a:t>B1</a:t>
+            </a:r>
+          </a:p>
+        </p:txBody>
+      </p:sp>
+      <p:sp>
+        <p:nvSpPr>
+          <p:cNvPr id="5" name="Rounded Rectangle 4"/>
+          <p:cNvSpPr/>
+          <p:nvPr/>
+        </p:nvSpPr>
+        <p:spPr>
+          <a:xfrm>
             <a:off x="8686800" y="182880"/>
             <a:ext cx="3200400" cy="640080"/>
           </a:xfrm>
@@ -11469,7 +12012,7 @@
       </p:sp>
       <p:sp>
         <p:nvSpPr>
-          <p:cNvPr id="5" name="Rounded Rectangle 4"/>
+          <p:cNvPr id="6" name="Rounded Rectangle 5"/>
           <p:cNvSpPr/>
           <p:nvPr/>
         </p:nvSpPr>
@@ -11514,7 +12057,7 @@
       </p:sp>
       <p:sp>
         <p:nvSpPr>
-          <p:cNvPr id="6" name="TextBox 5"/>
+          <p:cNvPr id="7" name="TextBox 6"/>
           <p:cNvSpPr txBox="1"/>
           <p:nvPr/>
         </p:nvSpPr>
@@ -11543,14 +12086,14 @@
               </a:defRPr>
             </a:pPr>
             <a:r>
-              <a:t>📷 Photo: A student carrying a backpack at school</a:t>
-            </a:r>
-          </a:p>
-        </p:txBody>
-      </p:sp>
-      <p:sp>
-        <p:nvSpPr>
-          <p:cNvPr id="7" name="TextBox 6"/>
+              <a:t>📷 Photo: A person inside a sleeping bag at a campsite in the mountains</a:t>
+            </a:r>
+          </a:p>
+        </p:txBody>
+      </p:sp>
+      <p:sp>
+        <p:nvSpPr>
+          <p:cNvPr id="8" name="TextBox 7"/>
           <p:cNvSpPr txBox="1"/>
           <p:nvPr/>
         </p:nvSpPr>
@@ -11579,14 +12122,14 @@
               </a:defRPr>
             </a:pPr>
             <a:r>
-              <a:t>🎒</a:t>
-            </a:r>
-          </a:p>
-        </p:txBody>
-      </p:sp>
-      <p:sp>
-        <p:nvSpPr>
-          <p:cNvPr id="8" name="TextBox 7"/>
+              <a:t>🛏️</a:t>
+            </a:r>
+          </a:p>
+        </p:txBody>
+      </p:sp>
+      <p:sp>
+        <p:nvSpPr>
+          <p:cNvPr id="9" name="TextBox 8"/>
           <p:cNvSpPr txBox="1"/>
           <p:nvPr/>
         </p:nvSpPr>
@@ -11622,7 +12165,7 @@
       </p:sp>
       <p:sp>
         <p:nvSpPr>
-          <p:cNvPr id="9" name="Rounded Rectangle 8"/>
+          <p:cNvPr id="10" name="Rounded Rectangle 9"/>
           <p:cNvSpPr/>
           <p:nvPr/>
         </p:nvSpPr>
@@ -11985,7 +12528,7 @@
               </a:defRPr>
             </a:pPr>
             <a:r>
-              <a:t>Suitcase</a:t>
+              <a:t>Blanket</a:t>
             </a:r>
           </a:p>
         </p:txBody>
@@ -12119,7 +12662,7 @@
               </a:defRPr>
             </a:pPr>
             <a:r>
-              <a:t>Wallet</a:t>
+              <a:t>Sleeping Bag</a:t>
             </a:r>
           </a:p>
         </p:txBody>
@@ -12253,7 +12796,7 @@
               </a:defRPr>
             </a:pPr>
             <a:r>
-              <a:t>Backpack</a:t>
+              <a:t>Tent</a:t>
             </a:r>
           </a:p>
         </p:txBody>
@@ -12289,7 +12832,7 @@
               </a:defRPr>
             </a:pPr>
             <a:r>
-              <a:t>✅ Correct Answer: C</a:t>
+              <a:t>✅ Correct Answer: B</a:t>
             </a:r>
           </a:p>
         </p:txBody>
@@ -12606,7 +13149,7 @@
               </a:defRPr>
             </a:pPr>
             <a:r>
-              <a:t>Answer: Backpack</a:t>
+              <a:t>Answer: Sleeping Bag</a:t>
             </a:r>
           </a:p>
         </p:txBody>
@@ -12685,7 +13228,7 @@
               </a:defRPr>
             </a:pPr>
             <a:r>
-              <a:t>carry — 運ぶ</a:t>
+              <a:t>zipper — ジッパー</a:t>
             </a:r>
           </a:p>
         </p:txBody>
@@ -12764,14 +13307,93 @@
               </a:defRPr>
             </a:pPr>
             <a:r>
-              <a:t>on your back — 背中に</a:t>
-            </a:r>
-          </a:p>
-        </p:txBody>
-      </p:sp>
-      <p:sp>
-        <p:nvSpPr>
-          <p:cNvPr id="12" name="Rounded Rectangle 11"/>
+              <a:t>insulated — 断熱された</a:t>
+            </a:r>
+          </a:p>
+        </p:txBody>
+      </p:sp>
+      <p:sp>
+        <p:nvSpPr>
+          <p:cNvPr id="12" name="Oval 11"/>
+          <p:cNvSpPr/>
+          <p:nvPr/>
+        </p:nvSpPr>
+        <p:spPr>
+          <a:xfrm>
+            <a:off x="1097280" y="3017520"/>
+            <a:ext cx="182880" cy="182880"/>
+          </a:xfrm>
+          <a:prstGeom prst="ellipse">
+            <a:avLst/>
+          </a:prstGeom>
+          <a:solidFill>
+            <a:srgbClr val="00B4D8"/>
+          </a:solidFill>
+          <a:ln>
+            <a:noFill/>
+          </a:ln>
+        </p:spPr>
+        <p:style>
+          <a:lnRef idx="1">
+            <a:schemeClr val="accent1"/>
+          </a:lnRef>
+          <a:fillRef idx="3">
+            <a:schemeClr val="accent1"/>
+          </a:fillRef>
+          <a:effectRef idx="2">
+            <a:schemeClr val="accent1"/>
+          </a:effectRef>
+          <a:fontRef idx="minor">
+            <a:schemeClr val="lt1"/>
+          </a:fontRef>
+        </p:style>
+        <p:txBody>
+          <a:bodyPr rtlCol="0" anchor="ctr"/>
+          <a:lstStyle/>
+          <a:p>
+            <a:pPr algn="ctr"/>
+          </a:p>
+        </p:txBody>
+      </p:sp>
+      <p:sp>
+        <p:nvSpPr>
+          <p:cNvPr id="13" name="TextBox 12"/>
+          <p:cNvSpPr txBox="1"/>
+          <p:nvPr/>
+        </p:nvSpPr>
+        <p:spPr>
+          <a:xfrm>
+            <a:off x="1463040" y="2926080"/>
+            <a:ext cx="9144000" cy="457200"/>
+          </a:xfrm>
+          <a:prstGeom prst="rect">
+            <a:avLst/>
+          </a:prstGeom>
+          <a:noFill/>
+        </p:spPr>
+        <p:txBody>
+          <a:bodyPr wrap="square" anchor="ctr">
+            <a:spAutoFit/>
+          </a:bodyPr>
+          <a:lstStyle/>
+          <a:p>
+            <a:pPr algn="l">
+              <a:defRPr sz="1800" b="1">
+                <a:solidFill>
+                  <a:srgbClr val="333333"/>
+                </a:solidFill>
+                <a:latin typeface="Calibri"/>
+              </a:defRPr>
+            </a:pPr>
+            <a:r>
+              <a:t>portable — 持ち運びできる</a:t>
+            </a:r>
+          </a:p>
+        </p:txBody>
+      </p:sp>
+      <p:sp>
+        <p:nvSpPr>
+          <p:cNvPr id="14" name="Rounded Rectangle 13"/>
           <p:cNvSpPr/>
           <p:nvPr/>
         </p:nvSpPr>
@@ -12815,14 +13437,14 @@
                   <a:srgbClr val="333333"/>
                 </a:solidFill>
               </a:rPr>
-              <a:t>📝 Can + verb (ability)</a:t>
-            </a:r>
-          </a:p>
-        </p:txBody>
-      </p:sp>
-      <p:sp>
-        <p:nvSpPr>
-          <p:cNvPr id="13" name="Rectangle 12"/>
+              <a:t>📝 Relative clause: which + verb</a:t>
+            </a:r>
+          </a:p>
+        </p:txBody>
+      </p:sp>
+      <p:sp>
+        <p:nvSpPr>
+          <p:cNvPr id="15" name="Rectangle 14"/>
           <p:cNvSpPr/>
           <p:nvPr/>
         </p:nvSpPr>
@@ -12865,7 +13487,7 @@
       </p:sp>
       <p:sp>
         <p:nvSpPr>
-          <p:cNvPr id="14" name="Rounded Rectangle 13"/>
+          <p:cNvPr id="16" name="Rounded Rectangle 15"/>
           <p:cNvSpPr/>
           <p:nvPr/>
         </p:nvSpPr>
@@ -12910,7 +13532,7 @@
       </p:sp>
       <p:sp>
         <p:nvSpPr>
-          <p:cNvPr id="15" name="TextBox 14"/>
+          <p:cNvPr id="17" name="TextBox 16"/>
           <p:cNvSpPr txBox="1"/>
           <p:nvPr/>
         </p:nvSpPr>
@@ -12939,7 +13561,7 @@
               </a:defRPr>
             </a:pPr>
             <a:r>
-              <a:t>Students carry it on their back. You can put books and lunch inside it.</a:t>
+              <a:t>It is a portable item you use when you camp outdoors. You get inside it to stay warm at night. It has a zipper and you can roll it up, unlike a blanket which has no zipper.</a:t>
             </a:r>
           </a:p>
         </p:txBody>
@@ -13086,6 +13708,57 @@
         </p:nvSpPr>
         <p:spPr>
           <a:xfrm>
+            <a:off x="4754880" y="182880"/>
+            <a:ext cx="1371600" cy="640080"/>
+          </a:xfrm>
+          <a:prstGeom prst="roundRect">
+            <a:avLst/>
+          </a:prstGeom>
+          <a:solidFill>
+            <a:srgbClr val="FF4500"/>
+          </a:solidFill>
+          <a:ln>
+            <a:noFill/>
+          </a:ln>
+        </p:spPr>
+        <p:style>
+          <a:lnRef idx="1">
+            <a:schemeClr val="accent1"/>
+          </a:lnRef>
+          <a:fillRef idx="3">
+            <a:schemeClr val="accent1"/>
+          </a:fillRef>
+          <a:effectRef idx="2">
+            <a:schemeClr val="accent1"/>
+          </a:effectRef>
+          <a:fontRef idx="minor">
+            <a:schemeClr val="lt1"/>
+          </a:fontRef>
+        </p:style>
+        <p:txBody>
+          <a:bodyPr rtlCol="0" anchor="ctr"/>
+          <a:lstStyle/>
+          <a:p>
+            <a:pPr algn="ctr"/>
+            <a:r>
+              <a:rPr sz="1800" b="1">
+                <a:solidFill>
+                  <a:srgbClr val="FFFFFF"/>
+                </a:solidFill>
+              </a:rPr>
+              <a:t>B1</a:t>
+            </a:r>
+          </a:p>
+        </p:txBody>
+      </p:sp>
+      <p:sp>
+        <p:nvSpPr>
+          <p:cNvPr id="5" name="Rounded Rectangle 4"/>
+          <p:cNvSpPr/>
+          <p:nvPr/>
+        </p:nvSpPr>
+        <p:spPr>
+          <a:xfrm>
             <a:off x="8686800" y="182880"/>
             <a:ext cx="3200400" cy="640080"/>
           </a:xfrm>
@@ -13131,7 +13804,7 @@
       </p:sp>
       <p:sp>
         <p:nvSpPr>
-          <p:cNvPr id="5" name="Rounded Rectangle 4"/>
+          <p:cNvPr id="6" name="Rounded Rectangle 5"/>
           <p:cNvSpPr/>
           <p:nvPr/>
         </p:nvSpPr>
@@ -13176,7 +13849,7 @@
       </p:sp>
       <p:sp>
         <p:nvSpPr>
-          <p:cNvPr id="6" name="TextBox 5"/>
+          <p:cNvPr id="7" name="TextBox 6"/>
           <p:cNvSpPr txBox="1"/>
           <p:nvPr/>
         </p:nvSpPr>
@@ -13205,14 +13878,14 @@
               </a:defRPr>
             </a:pPr>
             <a:r>
-              <a:t>📷 Photo: A colorful ice cream cone with multiple scoops</a:t>
-            </a:r>
-          </a:p>
-        </p:txBody>
-      </p:sp>
-      <p:sp>
-        <p:nvSpPr>
-          <p:cNvPr id="7" name="TextBox 6"/>
+              <a:t>📷 Photo: A cup of yogurt with fruit toppings on a table</a:t>
+            </a:r>
+          </a:p>
+        </p:txBody>
+      </p:sp>
+      <p:sp>
+        <p:nvSpPr>
+          <p:cNvPr id="8" name="TextBox 7"/>
           <p:cNvSpPr txBox="1"/>
           <p:nvPr/>
         </p:nvSpPr>
@@ -13241,14 +13914,14 @@
               </a:defRPr>
             </a:pPr>
             <a:r>
-              <a:t>🍦</a:t>
-            </a:r>
-          </a:p>
-        </p:txBody>
-      </p:sp>
-      <p:sp>
-        <p:nvSpPr>
-          <p:cNvPr id="8" name="TextBox 7"/>
+              <a:t>🥛</a:t>
+            </a:r>
+          </a:p>
+        </p:txBody>
+      </p:sp>
+      <p:sp>
+        <p:nvSpPr>
+          <p:cNvPr id="9" name="TextBox 8"/>
           <p:cNvSpPr txBox="1"/>
           <p:nvPr/>
         </p:nvSpPr>
@@ -13284,7 +13957,7 @@
       </p:sp>
       <p:sp>
         <p:nvSpPr>
-          <p:cNvPr id="9" name="Rounded Rectangle 8"/>
+          <p:cNvPr id="10" name="Rounded Rectangle 9"/>
           <p:cNvSpPr/>
           <p:nvPr/>
         </p:nvSpPr>
@@ -13647,7 +14320,7 @@
               </a:defRPr>
             </a:pPr>
             <a:r>
-              <a:t>Cake</a:t>
+              <a:t>Pudding</a:t>
             </a:r>
           </a:p>
         </p:txBody>
@@ -13781,7 +14454,7 @@
               </a:defRPr>
             </a:pPr>
             <a:r>
-              <a:t>Ice Cream</a:t>
+              <a:t>Yogurt</a:t>
             </a:r>
           </a:p>
         </p:txBody>
@@ -13915,7 +14588,7 @@
               </a:defRPr>
             </a:pPr>
             <a:r>
-              <a:t>Chocolate</a:t>
+              <a:t>Ice Cream</a:t>
             </a:r>
           </a:p>
         </p:txBody>
@@ -14268,7 +14941,7 @@
               </a:defRPr>
             </a:pPr>
             <a:r>
-              <a:t>Answer: Ice Cream</a:t>
+              <a:t>Answer: Yogurt</a:t>
             </a:r>
           </a:p>
         </p:txBody>
@@ -14347,7 +15020,7 @@
               </a:defRPr>
             </a:pPr>
             <a:r>
-              <a:t>cold — 冷たい</a:t>
+              <a:t>fermented — 発酵した</a:t>
             </a:r>
           </a:p>
         </p:txBody>
@@ -14426,14 +15099,93 @@
               </a:defRPr>
             </a:pPr>
             <a:r>
-              <a:t>melt — 溶ける</a:t>
-            </a:r>
-          </a:p>
-        </p:txBody>
-      </p:sp>
-      <p:sp>
-        <p:nvSpPr>
-          <p:cNvPr id="12" name="Rounded Rectangle 11"/>
+              <a:t>bacteria — 細菌、バクテリア</a:t>
+            </a:r>
+          </a:p>
+        </p:txBody>
+      </p:sp>
+      <p:sp>
+        <p:nvSpPr>
+          <p:cNvPr id="12" name="Oval 11"/>
+          <p:cNvSpPr/>
+          <p:nvPr/>
+        </p:nvSpPr>
+        <p:spPr>
+          <a:xfrm>
+            <a:off x="1097280" y="3017520"/>
+            <a:ext cx="182880" cy="182880"/>
+          </a:xfrm>
+          <a:prstGeom prst="ellipse">
+            <a:avLst/>
+          </a:prstGeom>
+          <a:solidFill>
+            <a:srgbClr val="00B4D8"/>
+          </a:solidFill>
+          <a:ln>
+            <a:noFill/>
+          </a:ln>
+        </p:spPr>
+        <p:style>
+          <a:lnRef idx="1">
+            <a:schemeClr val="accent1"/>
+          </a:lnRef>
+          <a:fillRef idx="3">
+            <a:schemeClr val="accent1"/>
+          </a:fillRef>
+          <a:effectRef idx="2">
+            <a:schemeClr val="accent1"/>
+          </a:effectRef>
+          <a:fontRef idx="minor">
+            <a:schemeClr val="lt1"/>
+          </a:fontRef>
+        </p:style>
+        <p:txBody>
+          <a:bodyPr rtlCol="0" anchor="ctr"/>
+          <a:lstStyle/>
+          <a:p>
+            <a:pPr algn="ctr"/>
+          </a:p>
+        </p:txBody>
+      </p:sp>
+      <p:sp>
+        <p:nvSpPr>
+          <p:cNvPr id="13" name="TextBox 12"/>
+          <p:cNvSpPr txBox="1"/>
+          <p:nvPr/>
+        </p:nvSpPr>
+        <p:spPr>
+          <a:xfrm>
+            <a:off x="1463040" y="2926080"/>
+            <a:ext cx="9144000" cy="457200"/>
+          </a:xfrm>
+          <a:prstGeom prst="rect">
+            <a:avLst/>
+          </a:prstGeom>
+          <a:noFill/>
+        </p:spPr>
+        <p:txBody>
+          <a:bodyPr wrap="square" anchor="ctr">
+            <a:spAutoFit/>
+          </a:bodyPr>
+          <a:lstStyle/>
+          <a:p>
+            <a:pPr algn="l">
+              <a:defRPr sz="1800" b="1">
+                <a:solidFill>
+                  <a:srgbClr val="333333"/>
+                </a:solidFill>
+                <a:latin typeface="Calibri"/>
+              </a:defRPr>
+            </a:pPr>
+            <a:r>
+              <a:t>sour — 酸っぱい</a:t>
+            </a:r>
+          </a:p>
+        </p:txBody>
+      </p:sp>
+      <p:sp>
+        <p:nvSpPr>
+          <p:cNvPr id="14" name="Rounded Rectangle 13"/>
           <p:cNvSpPr/>
           <p:nvPr/>
         </p:nvSpPr>
@@ -14477,14 +15229,14 @@
                   <a:srgbClr val="333333"/>
                 </a:solidFill>
               </a:rPr>
-              <a:t>📝 Adverb: quickly</a:t>
-            </a:r>
-          </a:p>
-        </p:txBody>
-      </p:sp>
-      <p:sp>
-        <p:nvSpPr>
-          <p:cNvPr id="13" name="Rectangle 12"/>
+              <a:t>📝 Contrast: unlike ~ / whereas ~</a:t>
+            </a:r>
+          </a:p>
+        </p:txBody>
+      </p:sp>
+      <p:sp>
+        <p:nvSpPr>
+          <p:cNvPr id="15" name="Rectangle 14"/>
           <p:cNvSpPr/>
           <p:nvPr/>
         </p:nvSpPr>
@@ -14527,7 +15279,7 @@
       </p:sp>
       <p:sp>
         <p:nvSpPr>
-          <p:cNvPr id="14" name="Rounded Rectangle 13"/>
+          <p:cNvPr id="16" name="Rounded Rectangle 15"/>
           <p:cNvSpPr/>
           <p:nvPr/>
         </p:nvSpPr>
@@ -14572,7 +15324,7 @@
       </p:sp>
       <p:sp>
         <p:nvSpPr>
-          <p:cNvPr id="15" name="TextBox 14"/>
+          <p:cNvPr id="17" name="TextBox 16"/>
           <p:cNvSpPr txBox="1"/>
           <p:nvPr/>
         </p:nvSpPr>
@@ -14601,7 +15353,7 @@
               </a:defRPr>
             </a:pPr>
             <a:r>
-              <a:t>It is very cold and sweet. It melts quickly in summer. You can choose many flavors.</a:t>
+              <a:t>It is a dairy product made from fermented milk. It has a slightly sour taste and a creamy texture. Unlike ice cream, it is not frozen, and unlike pudding, it is made with bacteria that are good for your health.</a:t>
             </a:r>
           </a:p>
         </p:txBody>
@@ -14748,6 +15500,57 @@
         </p:nvSpPr>
         <p:spPr>
           <a:xfrm>
+            <a:off x="4754880" y="182880"/>
+            <a:ext cx="1371600" cy="640080"/>
+          </a:xfrm>
+          <a:prstGeom prst="roundRect">
+            <a:avLst/>
+          </a:prstGeom>
+          <a:solidFill>
+            <a:srgbClr val="FF4500"/>
+          </a:solidFill>
+          <a:ln>
+            <a:noFill/>
+          </a:ln>
+        </p:spPr>
+        <p:style>
+          <a:lnRef idx="1">
+            <a:schemeClr val="accent1"/>
+          </a:lnRef>
+          <a:fillRef idx="3">
+            <a:schemeClr val="accent1"/>
+          </a:fillRef>
+          <a:effectRef idx="2">
+            <a:schemeClr val="accent1"/>
+          </a:effectRef>
+          <a:fontRef idx="minor">
+            <a:schemeClr val="lt1"/>
+          </a:fontRef>
+        </p:style>
+        <p:txBody>
+          <a:bodyPr rtlCol="0" anchor="ctr"/>
+          <a:lstStyle/>
+          <a:p>
+            <a:pPr algn="ctr"/>
+            <a:r>
+              <a:rPr sz="1800" b="1">
+                <a:solidFill>
+                  <a:srgbClr val="FFFFFF"/>
+                </a:solidFill>
+              </a:rPr>
+              <a:t>B1</a:t>
+            </a:r>
+          </a:p>
+        </p:txBody>
+      </p:sp>
+      <p:sp>
+        <p:nvSpPr>
+          <p:cNvPr id="5" name="Rounded Rectangle 4"/>
+          <p:cNvSpPr/>
+          <p:nvPr/>
+        </p:nvSpPr>
+        <p:spPr>
+          <a:xfrm>
             <a:off x="8686800" y="182880"/>
             <a:ext cx="3200400" cy="640080"/>
           </a:xfrm>
@@ -14793,7 +15596,7 @@
       </p:sp>
       <p:sp>
         <p:nvSpPr>
-          <p:cNvPr id="5" name="Rounded Rectangle 4"/>
+          <p:cNvPr id="6" name="Rounded Rectangle 5"/>
           <p:cNvSpPr/>
           <p:nvPr/>
         </p:nvSpPr>
@@ -14838,7 +15641,7 @@
       </p:sp>
       <p:sp>
         <p:nvSpPr>
-          <p:cNvPr id="6" name="TextBox 5"/>
+          <p:cNvPr id="7" name="TextBox 6"/>
           <p:cNvSpPr txBox="1"/>
           <p:nvPr/>
         </p:nvSpPr>
@@ -14867,14 +15670,14 @@
               </a:defRPr>
             </a:pPr>
             <a:r>
-              <a:t>📷 Photo: An airplane flying high above the clouds in a blue sky</a:t>
-            </a:r>
-          </a:p>
-        </p:txBody>
-      </p:sp>
-      <p:sp>
-        <p:nvSpPr>
-          <p:cNvPr id="7" name="TextBox 6"/>
+              <a:t>📷 Photo: A submarine diving deep under the ocean surface</a:t>
+            </a:r>
+          </a:p>
+        </p:txBody>
+      </p:sp>
+      <p:sp>
+        <p:nvSpPr>
+          <p:cNvPr id="8" name="TextBox 7"/>
           <p:cNvSpPr txBox="1"/>
           <p:nvPr/>
         </p:nvSpPr>
@@ -14903,14 +15706,14 @@
               </a:defRPr>
             </a:pPr>
             <a:r>
-              <a:t>✈️</a:t>
-            </a:r>
-          </a:p>
-        </p:txBody>
-      </p:sp>
-      <p:sp>
-        <p:nvSpPr>
-          <p:cNvPr id="8" name="TextBox 7"/>
+              <a:t>🚢</a:t>
+            </a:r>
+          </a:p>
+        </p:txBody>
+      </p:sp>
+      <p:sp>
+        <p:nvSpPr>
+          <p:cNvPr id="9" name="TextBox 8"/>
           <p:cNvSpPr txBox="1"/>
           <p:nvPr/>
         </p:nvSpPr>
@@ -14946,7 +15749,7 @@
       </p:sp>
       <p:sp>
         <p:nvSpPr>
-          <p:cNvPr id="9" name="Rounded Rectangle 8"/>
+          <p:cNvPr id="10" name="Rounded Rectangle 9"/>
           <p:cNvSpPr/>
           <p:nvPr/>
         </p:nvSpPr>
@@ -15443,7 +16246,7 @@
               </a:defRPr>
             </a:pPr>
             <a:r>
-              <a:t>Car</a:t>
+              <a:t>Motorcycle</a:t>
             </a:r>
           </a:p>
         </p:txBody>
@@ -15932,7 +16735,7 @@
               </a:defRPr>
             </a:pPr>
             <a:r>
-              <a:t>Airplane</a:t>
+              <a:t>Ferry</a:t>
             </a:r>
           </a:p>
         </p:txBody>
@@ -16066,7 +16869,7 @@
               </a:defRPr>
             </a:pPr>
             <a:r>
-              <a:t>Helicopter</a:t>
+              <a:t>Submarine</a:t>
             </a:r>
           </a:p>
         </p:txBody>
@@ -16200,7 +17003,7 @@
               </a:defRPr>
             </a:pPr>
             <a:r>
-              <a:t>Rocket</a:t>
+              <a:t>Cruise Ship</a:t>
             </a:r>
           </a:p>
         </p:txBody>
@@ -16236,7 +17039,7 @@
               </a:defRPr>
             </a:pPr>
             <a:r>
-              <a:t>✅ Correct Answer: A</a:t>
+              <a:t>✅ Correct Answer: B</a:t>
             </a:r>
           </a:p>
         </p:txBody>
@@ -16553,7 +17356,7 @@
               </a:defRPr>
             </a:pPr>
             <a:r>
-              <a:t>Answer: Airplane</a:t>
+              <a:t>Answer: Submarine</a:t>
             </a:r>
           </a:p>
         </p:txBody>
@@ -16632,7 +17435,7 @@
               </a:defRPr>
             </a:pPr>
             <a:r>
-              <a:t>fly — 飛ぶ</a:t>
+              <a:t>dive — 潜る</a:t>
             </a:r>
           </a:p>
         </p:txBody>
@@ -16711,14 +17514,172 @@
               </a:defRPr>
             </a:pPr>
             <a:r>
-              <a:t>wings — 翼</a:t>
-            </a:r>
-          </a:p>
-        </p:txBody>
-      </p:sp>
-      <p:sp>
-        <p:nvSpPr>
-          <p:cNvPr id="12" name="Rounded Rectangle 11"/>
+              <a:t>surface — 水面</a:t>
+            </a:r>
+          </a:p>
+        </p:txBody>
+      </p:sp>
+      <p:sp>
+        <p:nvSpPr>
+          <p:cNvPr id="12" name="Oval 11"/>
+          <p:cNvSpPr/>
+          <p:nvPr/>
+        </p:nvSpPr>
+        <p:spPr>
+          <a:xfrm>
+            <a:off x="1097280" y="3017520"/>
+            <a:ext cx="182880" cy="182880"/>
+          </a:xfrm>
+          <a:prstGeom prst="ellipse">
+            <a:avLst/>
+          </a:prstGeom>
+          <a:solidFill>
+            <a:srgbClr val="00B4D8"/>
+          </a:solidFill>
+          <a:ln>
+            <a:noFill/>
+          </a:ln>
+        </p:spPr>
+        <p:style>
+          <a:lnRef idx="1">
+            <a:schemeClr val="accent1"/>
+          </a:lnRef>
+          <a:fillRef idx="3">
+            <a:schemeClr val="accent1"/>
+          </a:fillRef>
+          <a:effectRef idx="2">
+            <a:schemeClr val="accent1"/>
+          </a:effectRef>
+          <a:fontRef idx="minor">
+            <a:schemeClr val="lt1"/>
+          </a:fontRef>
+        </p:style>
+        <p:txBody>
+          <a:bodyPr rtlCol="0" anchor="ctr"/>
+          <a:lstStyle/>
+          <a:p>
+            <a:pPr algn="ctr"/>
+          </a:p>
+        </p:txBody>
+      </p:sp>
+      <p:sp>
+        <p:nvSpPr>
+          <p:cNvPr id="13" name="TextBox 12"/>
+          <p:cNvSpPr txBox="1"/>
+          <p:nvPr/>
+        </p:nvSpPr>
+        <p:spPr>
+          <a:xfrm>
+            <a:off x="1463040" y="2926080"/>
+            <a:ext cx="9144000" cy="457200"/>
+          </a:xfrm>
+          <a:prstGeom prst="rect">
+            <a:avLst/>
+          </a:prstGeom>
+          <a:noFill/>
+        </p:spPr>
+        <p:txBody>
+          <a:bodyPr wrap="square" anchor="ctr">
+            <a:spAutoFit/>
+          </a:bodyPr>
+          <a:lstStyle/>
+          <a:p>
+            <a:pPr algn="l">
+              <a:defRPr sz="1800" b="1">
+                <a:solidFill>
+                  <a:srgbClr val="333333"/>
+                </a:solidFill>
+                <a:latin typeface="Calibri"/>
+              </a:defRPr>
+            </a:pPr>
+            <a:r>
+              <a:t>crew — 乗組員</a:t>
+            </a:r>
+          </a:p>
+        </p:txBody>
+      </p:sp>
+      <p:sp>
+        <p:nvSpPr>
+          <p:cNvPr id="14" name="Oval 13"/>
+          <p:cNvSpPr/>
+          <p:nvPr/>
+        </p:nvSpPr>
+        <p:spPr>
+          <a:xfrm>
+            <a:off x="1097280" y="3474720"/>
+            <a:ext cx="182880" cy="182880"/>
+          </a:xfrm>
+          <a:prstGeom prst="ellipse">
+            <a:avLst/>
+          </a:prstGeom>
+          <a:solidFill>
+            <a:srgbClr val="FF6B8A"/>
+          </a:solidFill>
+          <a:ln>
+            <a:noFill/>
+          </a:ln>
+        </p:spPr>
+        <p:style>
+          <a:lnRef idx="1">
+            <a:schemeClr val="accent1"/>
+          </a:lnRef>
+          <a:fillRef idx="3">
+            <a:schemeClr val="accent1"/>
+          </a:fillRef>
+          <a:effectRef idx="2">
+            <a:schemeClr val="accent1"/>
+          </a:effectRef>
+          <a:fontRef idx="minor">
+            <a:schemeClr val="lt1"/>
+          </a:fontRef>
+        </p:style>
+        <p:txBody>
+          <a:bodyPr rtlCol="0" anchor="ctr"/>
+          <a:lstStyle/>
+          <a:p>
+            <a:pPr algn="ctr"/>
+          </a:p>
+        </p:txBody>
+      </p:sp>
+      <p:sp>
+        <p:nvSpPr>
+          <p:cNvPr id="15" name="TextBox 14"/>
+          <p:cNvSpPr txBox="1"/>
+          <p:nvPr/>
+        </p:nvSpPr>
+        <p:spPr>
+          <a:xfrm>
+            <a:off x="1463040" y="3383280"/>
+            <a:ext cx="9144000" cy="457200"/>
+          </a:xfrm>
+          <a:prstGeom prst="rect">
+            <a:avLst/>
+          </a:prstGeom>
+          <a:noFill/>
+        </p:spPr>
+        <p:txBody>
+          <a:bodyPr wrap="square" anchor="ctr">
+            <a:spAutoFit/>
+          </a:bodyPr>
+          <a:lstStyle/>
+          <a:p>
+            <a:pPr algn="l">
+              <a:defRPr sz="1800" b="1">
+                <a:solidFill>
+                  <a:srgbClr val="333333"/>
+                </a:solidFill>
+                <a:latin typeface="Calibri"/>
+              </a:defRPr>
+            </a:pPr>
+            <a:r>
+              <a:t>underwater — 水中の</a:t>
+            </a:r>
+          </a:p>
+        </p:txBody>
+      </p:sp>
+      <p:sp>
+        <p:nvSpPr>
+          <p:cNvPr id="16" name="Rounded Rectangle 15"/>
           <p:cNvSpPr/>
           <p:nvPr/>
         </p:nvSpPr>
@@ -16762,14 +17723,14 @@
                   <a:srgbClr val="333333"/>
                 </a:solidFill>
               </a:rPr>
-              <a:t>📝 Can + verb (ability)</a:t>
-            </a:r>
-          </a:p>
-        </p:txBody>
-      </p:sp>
-      <p:sp>
-        <p:nvSpPr>
-          <p:cNvPr id="13" name="Rectangle 12"/>
+              <a:t>📝 Reason clause: because ~</a:t>
+            </a:r>
+          </a:p>
+        </p:txBody>
+      </p:sp>
+      <p:sp>
+        <p:nvSpPr>
+          <p:cNvPr id="17" name="Rectangle 16"/>
           <p:cNvSpPr/>
           <p:nvPr/>
         </p:nvSpPr>
@@ -16812,7 +17773,7 @@
       </p:sp>
       <p:sp>
         <p:nvSpPr>
-          <p:cNvPr id="14" name="Rounded Rectangle 13"/>
+          <p:cNvPr id="18" name="Rounded Rectangle 17"/>
           <p:cNvSpPr/>
           <p:nvPr/>
         </p:nvSpPr>
@@ -16857,7 +17818,7 @@
       </p:sp>
       <p:sp>
         <p:nvSpPr>
-          <p:cNvPr id="15" name="TextBox 14"/>
+          <p:cNvPr id="19" name="TextBox 18"/>
           <p:cNvSpPr txBox="1"/>
           <p:nvPr/>
         </p:nvSpPr>
@@ -16886,7 +17847,7 @@
               </a:defRPr>
             </a:pPr>
             <a:r>
-              <a:t>It has wings and it can fly. It carries many people to different countries very fast.</a:t>
+              <a:t>It is a type of vessel that is designed to travel underwater. It can dive below the surface and stay there for a long time. The crew cannot open the windows because the water pressure outside is extremely high.</a:t>
             </a:r>
           </a:p>
         </p:txBody>
@@ -17282,7 +18243,7 @@
               </a:defRPr>
             </a:pPr>
             <a:r>
-              <a:t>wheel — 車輪</a:t>
+              <a:t>pedal — ペダル（足でこぐ部分）</a:t>
             </a:r>
           </a:p>
         </p:txBody>
@@ -17361,7 +18322,7 @@
               </a:defRPr>
             </a:pPr>
             <a:r>
-              <a:t>faster than walking — 歩くより早い（比較）</a:t>
+              <a:t>two wheels — 2つの車輪</a:t>
             </a:r>
           </a:p>
         </p:txBody>
@@ -17536,7 +18497,7 @@
               </a:defRPr>
             </a:pPr>
             <a:r>
-              <a:t>It has two wheels. You move it with your legs and go faster than walking.</a:t>
+              <a:t>It has two wheels. You push the pedals with your feet to move. It does not need gasoline.</a:t>
             </a:r>
           </a:p>
         </p:txBody>
@@ -17683,6 +18644,57 @@
         </p:nvSpPr>
         <p:spPr>
           <a:xfrm>
+            <a:off x="4754880" y="182880"/>
+            <a:ext cx="1371600" cy="640080"/>
+          </a:xfrm>
+          <a:prstGeom prst="roundRect">
+            <a:avLst/>
+          </a:prstGeom>
+          <a:solidFill>
+            <a:srgbClr val="00B4D8"/>
+          </a:solidFill>
+          <a:ln>
+            <a:noFill/>
+          </a:ln>
+        </p:spPr>
+        <p:style>
+          <a:lnRef idx="1">
+            <a:schemeClr val="accent1"/>
+          </a:lnRef>
+          <a:fillRef idx="3">
+            <a:schemeClr val="accent1"/>
+          </a:fillRef>
+          <a:effectRef idx="2">
+            <a:schemeClr val="accent1"/>
+          </a:effectRef>
+          <a:fontRef idx="minor">
+            <a:schemeClr val="lt1"/>
+          </a:fontRef>
+        </p:style>
+        <p:txBody>
+          <a:bodyPr rtlCol="0" anchor="ctr"/>
+          <a:lstStyle/>
+          <a:p>
+            <a:pPr algn="ctr"/>
+            <a:r>
+              <a:rPr sz="1800" b="1">
+                <a:solidFill>
+                  <a:srgbClr val="FFFFFF"/>
+                </a:solidFill>
+              </a:rPr>
+              <a:t>A2</a:t>
+            </a:r>
+          </a:p>
+        </p:txBody>
+      </p:sp>
+      <p:sp>
+        <p:nvSpPr>
+          <p:cNvPr id="5" name="Rounded Rectangle 4"/>
+          <p:cNvSpPr/>
+          <p:nvPr/>
+        </p:nvSpPr>
+        <p:spPr>
+          <a:xfrm>
             <a:off x="8686800" y="182880"/>
             <a:ext cx="3200400" cy="640080"/>
           </a:xfrm>
@@ -17728,7 +18740,7 @@
       </p:sp>
       <p:sp>
         <p:nvSpPr>
-          <p:cNvPr id="5" name="Rounded Rectangle 4"/>
+          <p:cNvPr id="6" name="Rounded Rectangle 5"/>
           <p:cNvSpPr/>
           <p:nvPr/>
         </p:nvSpPr>
@@ -17773,7 +18785,7 @@
       </p:sp>
       <p:sp>
         <p:nvSpPr>
-          <p:cNvPr id="6" name="TextBox 5"/>
+          <p:cNvPr id="7" name="TextBox 6"/>
           <p:cNvSpPr txBox="1"/>
           <p:nvPr/>
         </p:nvSpPr>
@@ -17802,14 +18814,14 @@
               </a:defRPr>
             </a:pPr>
             <a:r>
-              <a:t>📷 Photo: A colorful umbrella on a rainy day in a city</a:t>
-            </a:r>
-          </a:p>
-        </p:txBody>
-      </p:sp>
-      <p:sp>
-        <p:nvSpPr>
-          <p:cNvPr id="7" name="TextBox 6"/>
+              <a:t>📷 Photo: A person holding a colorful umbrella on a rainy street</a:t>
+            </a:r>
+          </a:p>
+        </p:txBody>
+      </p:sp>
+      <p:sp>
+        <p:nvSpPr>
+          <p:cNvPr id="8" name="TextBox 7"/>
           <p:cNvSpPr txBox="1"/>
           <p:nvPr/>
         </p:nvSpPr>
@@ -17845,7 +18857,7 @@
       </p:sp>
       <p:sp>
         <p:nvSpPr>
-          <p:cNvPr id="8" name="TextBox 7"/>
+          <p:cNvPr id="9" name="TextBox 8"/>
           <p:cNvSpPr txBox="1"/>
           <p:nvPr/>
         </p:nvSpPr>
@@ -17881,7 +18893,7 @@
       </p:sp>
       <p:sp>
         <p:nvSpPr>
-          <p:cNvPr id="9" name="Rounded Rectangle 8"/>
+          <p:cNvPr id="10" name="Rounded Rectangle 9"/>
           <p:cNvSpPr/>
           <p:nvPr/>
         </p:nvSpPr>
@@ -18244,7 +19256,7 @@
               </a:defRPr>
             </a:pPr>
             <a:r>
-              <a:t>Umbrella</a:t>
+              <a:t>Parasol</a:t>
             </a:r>
           </a:p>
         </p:txBody>
@@ -18378,7 +19390,7 @@
               </a:defRPr>
             </a:pPr>
             <a:r>
-              <a:t>Hat</a:t>
+              <a:t>Umbrella</a:t>
             </a:r>
           </a:p>
         </p:txBody>
@@ -18548,7 +19560,7 @@
               </a:defRPr>
             </a:pPr>
             <a:r>
-              <a:t>✅ Correct Answer: A</a:t>
+              <a:t>✅ Correct Answer: B</a:t>
             </a:r>
           </a:p>
         </p:txBody>
@@ -18944,7 +19956,7 @@
               </a:defRPr>
             </a:pPr>
             <a:r>
-              <a:t>rain — 雨</a:t>
+              <a:t>fold — 折りたたむ</a:t>
             </a:r>
           </a:p>
         </p:txBody>
@@ -19023,7 +20035,7 @@
               </a:defRPr>
             </a:pPr>
             <a:r>
-              <a:t>keep ~ dry — ～を乾いた状態に保つ</a:t>
+              <a:t>above your head — 頭の上に</a:t>
             </a:r>
           </a:p>
         </p:txBody>
@@ -19198,7 +20210,7 @@
               </a:defRPr>
             </a:pPr>
             <a:r>
-              <a:t>You use it when it rains. You open it above your head to keep dry.</a:t>
+              <a:t>You hold it above your head when it rains. You can fold it and put it in your bag.</a:t>
             </a:r>
           </a:p>
         </p:txBody>
@@ -19345,6 +20357,57 @@
         </p:nvSpPr>
         <p:spPr>
           <a:xfrm>
+            <a:off x="4754880" y="182880"/>
+            <a:ext cx="1371600" cy="640080"/>
+          </a:xfrm>
+          <a:prstGeom prst="roundRect">
+            <a:avLst/>
+          </a:prstGeom>
+          <a:solidFill>
+            <a:srgbClr val="00B4D8"/>
+          </a:solidFill>
+          <a:ln>
+            <a:noFill/>
+          </a:ln>
+        </p:spPr>
+        <p:style>
+          <a:lnRef idx="1">
+            <a:schemeClr val="accent1"/>
+          </a:lnRef>
+          <a:fillRef idx="3">
+            <a:schemeClr val="accent1"/>
+          </a:fillRef>
+          <a:effectRef idx="2">
+            <a:schemeClr val="accent1"/>
+          </a:effectRef>
+          <a:fontRef idx="minor">
+            <a:schemeClr val="lt1"/>
+          </a:fontRef>
+        </p:style>
+        <p:txBody>
+          <a:bodyPr rtlCol="0" anchor="ctr"/>
+          <a:lstStyle/>
+          <a:p>
+            <a:pPr algn="ctr"/>
+            <a:r>
+              <a:rPr sz="1800" b="1">
+                <a:solidFill>
+                  <a:srgbClr val="FFFFFF"/>
+                </a:solidFill>
+              </a:rPr>
+              <a:t>A2</a:t>
+            </a:r>
+          </a:p>
+        </p:txBody>
+      </p:sp>
+      <p:sp>
+        <p:nvSpPr>
+          <p:cNvPr id="5" name="Rounded Rectangle 4"/>
+          <p:cNvSpPr/>
+          <p:nvPr/>
+        </p:nvSpPr>
+        <p:spPr>
+          <a:xfrm>
             <a:off x="8686800" y="182880"/>
             <a:ext cx="3200400" cy="640080"/>
           </a:xfrm>
@@ -19390,7 +20453,7 @@
       </p:sp>
       <p:sp>
         <p:nvSpPr>
-          <p:cNvPr id="5" name="Rounded Rectangle 4"/>
+          <p:cNvPr id="6" name="Rounded Rectangle 5"/>
           <p:cNvSpPr/>
           <p:nvPr/>
         </p:nvSpPr>
@@ -19435,7 +20498,7 @@
       </p:sp>
       <p:sp>
         <p:nvSpPr>
-          <p:cNvPr id="6" name="TextBox 5"/>
+          <p:cNvPr id="7" name="TextBox 6"/>
           <p:cNvSpPr txBox="1"/>
           <p:nvPr/>
         </p:nvSpPr>
@@ -19464,14 +20527,14 @@
               </a:defRPr>
             </a:pPr>
             <a:r>
-              <a:t>📷 Photo: A grand piano in a concert hall with spotlight</a:t>
-            </a:r>
-          </a:p>
-        </p:txBody>
-      </p:sp>
-      <p:sp>
-        <p:nvSpPr>
-          <p:cNvPr id="7" name="TextBox 6"/>
+              <a:t>📷 Photo: A musician playing the violin on stage</a:t>
+            </a:r>
+          </a:p>
+        </p:txBody>
+      </p:sp>
+      <p:sp>
+        <p:nvSpPr>
+          <p:cNvPr id="8" name="TextBox 7"/>
           <p:cNvSpPr txBox="1"/>
           <p:nvPr/>
         </p:nvSpPr>
@@ -19500,14 +20563,14 @@
               </a:defRPr>
             </a:pPr>
             <a:r>
-              <a:t>🎹</a:t>
-            </a:r>
-          </a:p>
-        </p:txBody>
-      </p:sp>
-      <p:sp>
-        <p:nvSpPr>
-          <p:cNvPr id="8" name="TextBox 7"/>
+              <a:t>🎻</a:t>
+            </a:r>
+          </a:p>
+        </p:txBody>
+      </p:sp>
+      <p:sp>
+        <p:nvSpPr>
+          <p:cNvPr id="9" name="TextBox 8"/>
           <p:cNvSpPr txBox="1"/>
           <p:nvPr/>
         </p:nvSpPr>
@@ -19543,7 +20606,7 @@
       </p:sp>
       <p:sp>
         <p:nvSpPr>
-          <p:cNvPr id="9" name="Rounded Rectangle 8"/>
+          <p:cNvPr id="10" name="Rounded Rectangle 9"/>
           <p:cNvSpPr/>
           <p:nvPr/>
         </p:nvSpPr>
@@ -19906,7 +20969,7 @@
               </a:defRPr>
             </a:pPr>
             <a:r>
-              <a:t>Guitar</a:t>
+              <a:t>Cello</a:t>
             </a:r>
           </a:p>
         </p:txBody>
@@ -20040,7 +21103,7 @@
               </a:defRPr>
             </a:pPr>
             <a:r>
-              <a:t>Piano</a:t>
+              <a:t>Violin</a:t>
             </a:r>
           </a:p>
         </p:txBody>
@@ -20174,7 +21237,7 @@
               </a:defRPr>
             </a:pPr>
             <a:r>
-              <a:t>Drums</a:t>
+              <a:t>Guitar</a:t>
             </a:r>
           </a:p>
         </p:txBody>

</xml_diff>